<commit_message>
chore: update migration presentation file
</commit_message>
<xml_diff>
--- a/presentations/migrating_an_instance/from-clicks-to-code-jnuc2026.pptx
+++ b/presentations/migrating_an_instance/from-clicks-to-code-jnuc2026.pptx
@@ -612,7 +612,7 @@
           <a:p>
             <a:r>
               <a:rPr lang="en-US" dirty="0"/>
-              <a:t>November 2025 - the first real state in the repo. Mechanic: import first if the provider supports it - only fall back to apply where there's no import statement. The apply just sets the same values the UI shows, so nothing changes, but the resource lands in state. All settings panes done in about a day.</a:t>
+              <a:t>November 2025 - the first real state in the repo. Point at the id and say what it is: a constant the provider made up, because a singleton has nothing to be identified by. There is only one client check-in. So the import ceremony is optional. Match the resource to what the UI already shows, apply, and Terraform writes values that are already there - no change on the server, but it is now in state. Every settings resource done in about a day.</a:t>
             </a:r>
             <a:endParaRPr lang="en-US" dirty="0"/>
           </a:p>
@@ -1756,7 +1756,7 @@
           <a:p>
             <a:r>
               <a:rPr lang="en-US" dirty="0"/>
-              <a:t>Point at the provider registry, the jamfpy repo once it has a URL, and the other resources on screen; contact details still to confirm.</a:t>
+              <a:t>Where to send people. Start with the Deployment Theory Terraform registry and demo repo, and the training repo built for workplace engineers. Then the community and official set: Jamf developer docs, the Jamf blog IaC walkthrough, the MacAdmins Slack channel, and Neil Martin's starter repo. Point at the QR code on the right and leave this slide up while questions run - it opens a link to this presentation, so nobody needs to photograph the URLs.</a:t>
             </a:r>
             <a:endParaRPr lang="en-US" dirty="0"/>
           </a:p>

</xml_diff>